<commit_message>
fix: anonymize public operator identity and strengthen brand portfolio
</commit_message>
<xml_diff>
--- a/web/public/seminars/ashiba.pptx
+++ b/web/public/seminars/ashiba.pptx
@@ -3464,7 +3464,7 @@
                 <a:latin typeface="Meiryo"/>
                 <a:ea typeface="Meiryo"/>
               </a:rPr>
-              <a:t>ANZEN AI ／ 労働安全コンサルタント（登録番号260022・土木）監修</a:t>
+              <a:t>安全AIポータル編集部｜労働安全コンサルタント監修</a:t>
             </a:r>
           </a:p>
         </p:txBody>
@@ -3504,7 +3504,7 @@
                 <a:latin typeface="Meiryo"/>
                 <a:ea typeface="Meiryo"/>
               </a:rPr>
-              <a:t>ANZEN AI</a:t>
+              <a:t>安全AIポータル</a:t>
             </a:r>
           </a:p>
         </p:txBody>
@@ -4646,7 +4646,7 @@
                 <a:latin typeface="Meiryo"/>
                 <a:ea typeface="Meiryo"/>
               </a:rPr>
-              <a:t>safe-ai-site.vercel.app/contact</a:t>
+              <a:t>anzen-ai-portal.jp/contact</a:t>
             </a:r>
           </a:p>
         </p:txBody>
@@ -4686,7 +4686,7 @@
                 <a:latin typeface="Meiryo"/>
                 <a:ea typeface="Meiryo"/>
               </a:rPr>
-              <a:t>ANZEN AI ／ 労働安全コンサルタント（登録番号260022・土木）監修</a:t>
+              <a:t>安全AIポータル編集部｜労働安全コンサルタント監修</a:t>
             </a:r>
           </a:p>
         </p:txBody>
@@ -6128,7 +6128,7 @@
                 <a:latin typeface="Meiryo"/>
                 <a:ea typeface="Meiryo"/>
               </a:rPr>
-              <a:t>ANZEN AI ／ 労働安全コンサルタント（登録番号260022・土木）監修</a:t>
+              <a:t>安全AIポータル編集部｜労働安全コンサルタント監修</a:t>
             </a:r>
           </a:p>
         </p:txBody>
@@ -7518,7 +7518,7 @@
                 <a:latin typeface="Meiryo"/>
                 <a:ea typeface="Meiryo"/>
               </a:rPr>
-              <a:t>ANZEN AI ／ 労働安全コンサルタント（登録番号260022・土木）監修</a:t>
+              <a:t>安全AIポータル編集部｜労働安全コンサルタント監修</a:t>
             </a:r>
           </a:p>
         </p:txBody>
@@ -8620,7 +8620,7 @@
                 <a:latin typeface="Meiryo"/>
                 <a:ea typeface="Meiryo"/>
               </a:rPr>
-              <a:t>ANZEN AI ／ 労働安全コンサルタント（登録番号260022・土木）監修</a:t>
+              <a:t>安全AIポータル編集部｜労働安全コンサルタント監修</a:t>
             </a:r>
           </a:p>
         </p:txBody>
@@ -10938,7 +10938,7 @@
                 <a:latin typeface="Meiryo"/>
                 <a:ea typeface="Meiryo"/>
               </a:rPr>
-              <a:t>ANZEN AI ／ 労働安全コンサルタント（登録番号260022・土木）監修</a:t>
+              <a:t>安全AIポータル編集部｜労働安全コンサルタント監修</a:t>
             </a:r>
           </a:p>
         </p:txBody>
@@ -12377,7 +12377,7 @@
                 <a:latin typeface="Meiryo"/>
                 <a:ea typeface="Meiryo"/>
               </a:rPr>
-              <a:t>ANZEN AI ／ 労働安全コンサルタント（登録番号260022・土木）監修</a:t>
+              <a:t>安全AIポータル編集部｜労働安全コンサルタント監修</a:t>
             </a:r>
           </a:p>
         </p:txBody>
@@ -14251,7 +14251,7 @@
                 <a:latin typeface="Meiryo"/>
                 <a:ea typeface="Meiryo"/>
               </a:rPr>
-              <a:t>ANZEN AI ／ 労働安全コンサルタント（登録番号260022・土木）監修</a:t>
+              <a:t>安全AIポータル編集部｜労働安全コンサルタント監修</a:t>
             </a:r>
           </a:p>
         </p:txBody>
@@ -15563,7 +15563,7 @@
                 <a:latin typeface="Meiryo"/>
                 <a:ea typeface="Meiryo"/>
               </a:rPr>
-              <a:t>ANZEN AI ／ 労働安全コンサルタント（登録番号260022・土木）監修</a:t>
+              <a:t>安全AIポータル編集部｜労働安全コンサルタント監修</a:t>
             </a:r>
           </a:p>
         </p:txBody>
@@ -16665,7 +16665,7 @@
                 <a:latin typeface="Meiryo"/>
                 <a:ea typeface="Meiryo"/>
               </a:rPr>
-              <a:t>ANZEN AI ／ 労働安全コンサルタント（登録番号260022・土木）監修</a:t>
+              <a:t>安全AIポータル編集部｜労働安全コンサルタント監修</a:t>
             </a:r>
           </a:p>
         </p:txBody>

</xml_diff>